<commit_message>
drobné úpravy a ujasnenia
</commit_message>
<xml_diff>
--- a/LC UNIX/02 Multi-User Concepts.pptx
+++ b/LC UNIX/02 Multi-User Concepts.pptx
@@ -258,328 +258,29 @@
 </p:presentation>
 </file>
 
-<file path=ppt/revisionInfo.xml><?xml version="1.0" encoding="utf-8"?>
-<p1510:revInfo xmlns:a="http://schemas.openxmlformats.org/drawingml/2006/main" xmlns:r="http://schemas.openxmlformats.org/officeDocument/2006/relationships" xmlns:p1510="http://schemas.microsoft.com/office/powerpoint/2015/10/main">
-  <p1510:revLst>
-    <p1510:client id="{56715E6F-DEDE-CBCA-3CB3-D7BCCC4BEC8A}" v="4" dt="2025-03-14T09:24:42.620"/>
-  </p1510:revLst>
-</p1510:revInfo>
-</file>
-
 <file path=ppt/changesInfos/changesInfo1.xml><?xml version="1.0" encoding="utf-8"?>
 <pc:chgInfo xmlns:a="http://schemas.openxmlformats.org/drawingml/2006/main" xmlns:r="http://schemas.openxmlformats.org/officeDocument/2006/relationships" xmlns:ac="http://schemas.microsoft.com/office/drawing/2013/main/command" xmlns:pc="http://schemas.microsoft.com/office/powerpoint/2013/main/command">
   <pc:docChgLst>
-    <pc:chgData name="Baráth, Július" userId="S::julius.barath@aos.sk::aebde9b9-dccc-4475-a9ac-c05e78323d7a" providerId="AD" clId="Web-{56715E6F-DEDE-CBCA-3CB3-D7BCCC4BEC8A}"/>
-    <pc:docChg chg="modSld">
-      <pc:chgData name="Baráth, Július" userId="S::julius.barath@aos.sk::aebde9b9-dccc-4475-a9ac-c05e78323d7a" providerId="AD" clId="Web-{56715E6F-DEDE-CBCA-3CB3-D7BCCC4BEC8A}" dt="2025-03-14T09:24:42.620" v="3" actId="1076"/>
-      <pc:docMkLst>
-        <pc:docMk/>
-      </pc:docMkLst>
-      <pc:sldChg chg="modSp">
-        <pc:chgData name="Baráth, Július" userId="S::julius.barath@aos.sk::aebde9b9-dccc-4475-a9ac-c05e78323d7a" providerId="AD" clId="Web-{56715E6F-DEDE-CBCA-3CB3-D7BCCC4BEC8A}" dt="2025-03-14T08:47:53.481" v="1" actId="20577"/>
-        <pc:sldMkLst>
-          <pc:docMk/>
-          <pc:sldMk cId="0" sldId="259"/>
-        </pc:sldMkLst>
-        <pc:spChg chg="mod">
-          <ac:chgData name="Baráth, Július" userId="S::julius.barath@aos.sk::aebde9b9-dccc-4475-a9ac-c05e78323d7a" providerId="AD" clId="Web-{56715E6F-DEDE-CBCA-3CB3-D7BCCC4BEC8A}" dt="2025-03-14T08:47:53.481" v="1" actId="20577"/>
-          <ac:spMkLst>
-            <pc:docMk/>
-            <pc:sldMk cId="0" sldId="259"/>
-            <ac:spMk id="40" creationId="{00000000-0000-0000-0000-000000000000}"/>
-          </ac:spMkLst>
-        </pc:spChg>
-      </pc:sldChg>
-      <pc:sldChg chg="modSp">
-        <pc:chgData name="Baráth, Július" userId="S::julius.barath@aos.sk::aebde9b9-dccc-4475-a9ac-c05e78323d7a" providerId="AD" clId="Web-{56715E6F-DEDE-CBCA-3CB3-D7BCCC4BEC8A}" dt="2025-03-14T09:24:42.620" v="3" actId="1076"/>
-        <pc:sldMkLst>
-          <pc:docMk/>
-          <pc:sldMk cId="1313297711" sldId="274"/>
-        </pc:sldMkLst>
-        <pc:picChg chg="mod">
-          <ac:chgData name="Baráth, Július" userId="S::julius.barath@aos.sk::aebde9b9-dccc-4475-a9ac-c05e78323d7a" providerId="AD" clId="Web-{56715E6F-DEDE-CBCA-3CB3-D7BCCC4BEC8A}" dt="2025-03-14T09:24:42.620" v="3" actId="1076"/>
-          <ac:picMkLst>
-            <pc:docMk/>
-            <pc:sldMk cId="1313297711" sldId="274"/>
-            <ac:picMk id="4" creationId="{9A6793EB-1C78-9178-1E95-5B3456829883}"/>
-          </ac:picMkLst>
-        </pc:picChg>
-      </pc:sldChg>
-    </pc:docChg>
-  </pc:docChgLst>
-  <pc:docChgLst>
-    <pc:chgData name="Baráth, Július" userId="aebde9b9-dccc-4475-a9ac-c05e78323d7a" providerId="ADAL" clId="{F40F9804-3EE9-8642-822F-BE0B43426D1D}"/>
+    <pc:chgData name="Baráth, Július" userId="aebde9b9-dccc-4475-a9ac-c05e78323d7a" providerId="ADAL" clId="{4A0811C8-ED2F-505E-B787-C8270CED5046}"/>
     <pc:docChg chg="custSel modSld">
-      <pc:chgData name="Baráth, Július" userId="aebde9b9-dccc-4475-a9ac-c05e78323d7a" providerId="ADAL" clId="{F40F9804-3EE9-8642-822F-BE0B43426D1D}" dt="2024-03-05T15:15:39" v="9" actId="1076"/>
+      <pc:chgData name="Baráth, Július" userId="aebde9b9-dccc-4475-a9ac-c05e78323d7a" providerId="ADAL" clId="{4A0811C8-ED2F-505E-B787-C8270CED5046}" dt="2026-02-26T11:49:49.268" v="24" actId="20577"/>
       <pc:docMkLst>
         <pc:docMk/>
       </pc:docMkLst>
       <pc:sldChg chg="modSp mod">
-        <pc:chgData name="Baráth, Július" userId="aebde9b9-dccc-4475-a9ac-c05e78323d7a" providerId="ADAL" clId="{F40F9804-3EE9-8642-822F-BE0B43426D1D}" dt="2024-03-01T06:33:06.631" v="2" actId="20577"/>
-        <pc:sldMkLst>
-          <pc:docMk/>
-          <pc:sldMk cId="0" sldId="259"/>
-        </pc:sldMkLst>
-      </pc:sldChg>
-      <pc:sldChg chg="addSp delSp modSp mod">
-        <pc:chgData name="Baráth, Július" userId="aebde9b9-dccc-4475-a9ac-c05e78323d7a" providerId="ADAL" clId="{F40F9804-3EE9-8642-822F-BE0B43426D1D}" dt="2024-03-05T15:15:39" v="9" actId="1076"/>
-        <pc:sldMkLst>
-          <pc:docMk/>
-          <pc:sldMk cId="0" sldId="267"/>
-        </pc:sldMkLst>
-      </pc:sldChg>
-    </pc:docChg>
-  </pc:docChgLst>
-  <pc:docChgLst>
-    <pc:chgData name="Július Baráth" userId="e650c4ab-697e-4750-bd58-c1531aabce95" providerId="ADAL" clId="{6EE7587A-6E72-4F23-BFFB-1823C5EB908C}"/>
-    <pc:docChg chg="modSld">
-      <pc:chgData name="Július Baráth" userId="e650c4ab-697e-4750-bd58-c1531aabce95" providerId="ADAL" clId="{6EE7587A-6E72-4F23-BFFB-1823C5EB908C}" dt="2022-03-15T08:04:37.934" v="1" actId="1076"/>
-      <pc:docMkLst>
-        <pc:docMk/>
-      </pc:docMkLst>
-      <pc:sldChg chg="addSp modSp mod">
-        <pc:chgData name="Július Baráth" userId="e650c4ab-697e-4750-bd58-c1531aabce95" providerId="ADAL" clId="{6EE7587A-6E72-4F23-BFFB-1823C5EB908C}" dt="2022-03-15T08:04:37.934" v="1" actId="1076"/>
-        <pc:sldMkLst>
-          <pc:docMk/>
-          <pc:sldMk cId="0" sldId="261"/>
-        </pc:sldMkLst>
-      </pc:sldChg>
-    </pc:docChg>
-  </pc:docChgLst>
-  <pc:docChgLst>
-    <pc:chgData name="Baráth, Július" userId="S::julius.barath@aos.sk::aebde9b9-dccc-4475-a9ac-c05e78323d7a" providerId="AD" clId="Web-{6FC91501-39AF-3816-FF38-0629A073B8E9}"/>
-    <pc:docChg chg="addSld delSld modSld">
-      <pc:chgData name="Baráth, Július" userId="S::julius.barath@aos.sk::aebde9b9-dccc-4475-a9ac-c05e78323d7a" providerId="AD" clId="Web-{6FC91501-39AF-3816-FF38-0629A073B8E9}" dt="2023-12-18T10:33:53.611" v="25"/>
-      <pc:docMkLst>
-        <pc:docMk/>
-      </pc:docMkLst>
-      <pc:sldChg chg="del">
-        <pc:chgData name="Baráth, Július" userId="S::julius.barath@aos.sk::aebde9b9-dccc-4475-a9ac-c05e78323d7a" providerId="AD" clId="Web-{6FC91501-39AF-3816-FF38-0629A073B8E9}" dt="2023-12-18T10:33:10.641" v="22"/>
-        <pc:sldMkLst>
-          <pc:docMk/>
-          <pc:sldMk cId="0" sldId="268"/>
-        </pc:sldMkLst>
-      </pc:sldChg>
-      <pc:sldChg chg="del">
-        <pc:chgData name="Baráth, Július" userId="S::julius.barath@aos.sk::aebde9b9-dccc-4475-a9ac-c05e78323d7a" providerId="AD" clId="Web-{6FC91501-39AF-3816-FF38-0629A073B8E9}" dt="2023-12-18T10:33:34.579" v="23"/>
-        <pc:sldMkLst>
-          <pc:docMk/>
-          <pc:sldMk cId="0" sldId="269"/>
-        </pc:sldMkLst>
-      </pc:sldChg>
-      <pc:sldChg chg="del">
-        <pc:chgData name="Baráth, Július" userId="S::julius.barath@aos.sk::aebde9b9-dccc-4475-a9ac-c05e78323d7a" providerId="AD" clId="Web-{6FC91501-39AF-3816-FF38-0629A073B8E9}" dt="2023-12-18T10:33:41.611" v="24"/>
-        <pc:sldMkLst>
-          <pc:docMk/>
-          <pc:sldMk cId="0" sldId="270"/>
-        </pc:sldMkLst>
-      </pc:sldChg>
-      <pc:sldChg chg="del">
-        <pc:chgData name="Baráth, Július" userId="S::julius.barath@aos.sk::aebde9b9-dccc-4475-a9ac-c05e78323d7a" providerId="AD" clId="Web-{6FC91501-39AF-3816-FF38-0629A073B8E9}" dt="2023-12-18T10:33:53.611" v="25"/>
-        <pc:sldMkLst>
-          <pc:docMk/>
-          <pc:sldMk cId="0" sldId="272"/>
-        </pc:sldMkLst>
-      </pc:sldChg>
-      <pc:sldChg chg="modSp add del mod modClrScheme chgLayout">
-        <pc:chgData name="Baráth, Július" userId="S::julius.barath@aos.sk::aebde9b9-dccc-4475-a9ac-c05e78323d7a" providerId="AD" clId="Web-{6FC91501-39AF-3816-FF38-0629A073B8E9}" dt="2023-12-18T10:32:36.874" v="17"/>
-        <pc:sldMkLst>
-          <pc:docMk/>
-          <pc:sldMk cId="2394271429" sldId="276"/>
-        </pc:sldMkLst>
-      </pc:sldChg>
-      <pc:sldChg chg="addSp delSp modSp add mod modClrScheme chgLayout">
-        <pc:chgData name="Baráth, Július" userId="S::julius.barath@aos.sk::aebde9b9-dccc-4475-a9ac-c05e78323d7a" providerId="AD" clId="Web-{6FC91501-39AF-3816-FF38-0629A073B8E9}" dt="2023-12-18T10:32:06.732" v="15" actId="1076"/>
-        <pc:sldMkLst>
-          <pc:docMk/>
-          <pc:sldMk cId="1305714434" sldId="277"/>
-        </pc:sldMkLst>
-      </pc:sldChg>
-      <pc:sldChg chg="modSp add mod modClrScheme chgLayout">
-        <pc:chgData name="Baráth, Július" userId="S::julius.barath@aos.sk::aebde9b9-dccc-4475-a9ac-c05e78323d7a" providerId="AD" clId="Web-{6FC91501-39AF-3816-FF38-0629A073B8E9}" dt="2023-12-18T10:32:55.953" v="21" actId="20577"/>
-        <pc:sldMkLst>
-          <pc:docMk/>
-          <pc:sldMk cId="3759222479" sldId="278"/>
-        </pc:sldMkLst>
-      </pc:sldChg>
-      <pc:sldChg chg="new del">
-        <pc:chgData name="Baráth, Július" userId="S::julius.barath@aos.sk::aebde9b9-dccc-4475-a9ac-c05e78323d7a" providerId="AD" clId="Web-{6FC91501-39AF-3816-FF38-0629A073B8E9}" dt="2023-12-18T10:30:08.977" v="4"/>
-        <pc:sldMkLst>
-          <pc:docMk/>
-          <pc:sldMk cId="1741312607" sldId="279"/>
-        </pc:sldMkLst>
-      </pc:sldChg>
-      <pc:sldMasterChg chg="addSldLayout">
-        <pc:chgData name="Baráth, Július" userId="S::julius.barath@aos.sk::aebde9b9-dccc-4475-a9ac-c05e78323d7a" providerId="AD" clId="Web-{6FC91501-39AF-3816-FF38-0629A073B8E9}" dt="2023-12-18T10:29:30.960" v="1"/>
-        <pc:sldMasterMkLst>
-          <pc:docMk/>
-          <pc:sldMasterMk cId="0" sldId="2147483653"/>
-        </pc:sldMasterMkLst>
-        <pc:sldLayoutChg chg="add replId">
-          <pc:chgData name="Baráth, Július" userId="S::julius.barath@aos.sk::aebde9b9-dccc-4475-a9ac-c05e78323d7a" providerId="AD" clId="Web-{6FC91501-39AF-3816-FF38-0629A073B8E9}" dt="2023-12-18T10:29:30.913" v="0"/>
-          <pc:sldLayoutMkLst>
-            <pc:docMk/>
-            <pc:sldMasterMk cId="0" sldId="2147483653"/>
-            <pc:sldLayoutMk cId="2744229444" sldId="2147483654"/>
-          </pc:sldLayoutMkLst>
-        </pc:sldLayoutChg>
-        <pc:sldLayoutChg chg="add">
-          <pc:chgData name="Baráth, Július" userId="S::julius.barath@aos.sk::aebde9b9-dccc-4475-a9ac-c05e78323d7a" providerId="AD" clId="Web-{6FC91501-39AF-3816-FF38-0629A073B8E9}" dt="2023-12-18T10:29:30.960" v="1"/>
-          <pc:sldLayoutMkLst>
-            <pc:docMk/>
-            <pc:sldMasterMk cId="0" sldId="2147483653"/>
-            <pc:sldLayoutMk cId="2258777207" sldId="2147483655"/>
-          </pc:sldLayoutMkLst>
-        </pc:sldLayoutChg>
-      </pc:sldMasterChg>
-    </pc:docChg>
-  </pc:docChgLst>
-  <pc:docChgLst>
-    <pc:chgData name="Baráth, Július" userId="S::julius.barath@aos.sk::aebde9b9-dccc-4475-a9ac-c05e78323d7a" providerId="AD" clId="Web-{67A21A13-77C8-0066-BC70-86EECF129135}"/>
-    <pc:docChg chg="modSld">
-      <pc:chgData name="Baráth, Július" userId="S::julius.barath@aos.sk::aebde9b9-dccc-4475-a9ac-c05e78323d7a" providerId="AD" clId="Web-{67A21A13-77C8-0066-BC70-86EECF129135}" dt="2025-03-13T09:12:40.882" v="55" actId="20577"/>
-      <pc:docMkLst>
-        <pc:docMk/>
-      </pc:docMkLst>
-      <pc:sldChg chg="modSp">
-        <pc:chgData name="Baráth, Július" userId="S::julius.barath@aos.sk::aebde9b9-dccc-4475-a9ac-c05e78323d7a" providerId="AD" clId="Web-{67A21A13-77C8-0066-BC70-86EECF129135}" dt="2025-03-13T09:09:23.249" v="25" actId="20577"/>
-        <pc:sldMkLst>
-          <pc:docMk/>
-          <pc:sldMk cId="0" sldId="263"/>
-        </pc:sldMkLst>
-        <pc:spChg chg="mod">
-          <ac:chgData name="Baráth, Július" userId="S::julius.barath@aos.sk::aebde9b9-dccc-4475-a9ac-c05e78323d7a" providerId="AD" clId="Web-{67A21A13-77C8-0066-BC70-86EECF129135}" dt="2025-03-13T09:09:23.249" v="25" actId="20577"/>
-          <ac:spMkLst>
-            <pc:docMk/>
-            <pc:sldMk cId="0" sldId="263"/>
-            <ac:spMk id="68" creationId="{00000000-0000-0000-0000-000000000000}"/>
-          </ac:spMkLst>
-        </pc:spChg>
-      </pc:sldChg>
-      <pc:sldChg chg="modSp">
-        <pc:chgData name="Baráth, Július" userId="S::julius.barath@aos.sk::aebde9b9-dccc-4475-a9ac-c05e78323d7a" providerId="AD" clId="Web-{67A21A13-77C8-0066-BC70-86EECF129135}" dt="2025-03-13T09:12:40.882" v="55" actId="20577"/>
-        <pc:sldMkLst>
-          <pc:docMk/>
-          <pc:sldMk cId="0" sldId="267"/>
-        </pc:sldMkLst>
-        <pc:spChg chg="mod">
-          <ac:chgData name="Baráth, Július" userId="S::julius.barath@aos.sk::aebde9b9-dccc-4475-a9ac-c05e78323d7a" providerId="AD" clId="Web-{67A21A13-77C8-0066-BC70-86EECF129135}" dt="2025-03-13T09:12:40.882" v="55" actId="20577"/>
-          <ac:spMkLst>
-            <pc:docMk/>
-            <pc:sldMk cId="0" sldId="267"/>
-            <ac:spMk id="96" creationId="{00000000-0000-0000-0000-000000000000}"/>
-          </ac:spMkLst>
-        </pc:spChg>
-      </pc:sldChg>
-    </pc:docChg>
-  </pc:docChgLst>
-  <pc:docChgLst>
-    <pc:chgData name="Baráth, Július" userId="aebde9b9-dccc-4475-a9ac-c05e78323d7a" providerId="ADAL" clId="{1C1F4400-165D-B844-ACCB-45A0B0E67B12}"/>
-    <pc:docChg chg="modSld">
-      <pc:chgData name="Baráth, Július" userId="aebde9b9-dccc-4475-a9ac-c05e78323d7a" providerId="ADAL" clId="{1C1F4400-165D-B844-ACCB-45A0B0E67B12}" dt="2023-03-13T12:17:12.984" v="3" actId="1076"/>
-      <pc:docMkLst>
-        <pc:docMk/>
-      </pc:docMkLst>
-      <pc:sldChg chg="addSp modSp mod">
-        <pc:chgData name="Baráth, Július" userId="aebde9b9-dccc-4475-a9ac-c05e78323d7a" providerId="ADAL" clId="{1C1F4400-165D-B844-ACCB-45A0B0E67B12}" dt="2023-03-13T12:17:12.984" v="3" actId="1076"/>
-        <pc:sldMkLst>
-          <pc:docMk/>
-          <pc:sldMk cId="0" sldId="267"/>
-        </pc:sldMkLst>
-      </pc:sldChg>
-    </pc:docChg>
-  </pc:docChgLst>
-  <pc:docChgLst>
-    <pc:chgData name="Baráth, Július" userId="S::julius.barath@aos.sk::aebde9b9-dccc-4475-a9ac-c05e78323d7a" providerId="AD" clId="Web-{5EE20A90-31EA-7549-7211-B0E9BADCD073}"/>
-    <pc:docChg chg="addSld delSld modSld">
-      <pc:chgData name="Baráth, Július" userId="S::julius.barath@aos.sk::aebde9b9-dccc-4475-a9ac-c05e78323d7a" providerId="AD" clId="Web-{5EE20A90-31EA-7549-7211-B0E9BADCD073}" dt="2023-12-18T10:22:13.433" v="19" actId="14100"/>
-      <pc:docMkLst>
-        <pc:docMk/>
-      </pc:docMkLst>
-      <pc:sldChg chg="new del">
-        <pc:chgData name="Baráth, Július" userId="S::julius.barath@aos.sk::aebde9b9-dccc-4475-a9ac-c05e78323d7a" providerId="AD" clId="Web-{5EE20A90-31EA-7549-7211-B0E9BADCD073}" dt="2023-12-18T10:19:15.929" v="2"/>
-        <pc:sldMkLst>
-          <pc:docMk/>
-          <pc:sldMk cId="1036998771" sldId="273"/>
-        </pc:sldMkLst>
-      </pc:sldChg>
-      <pc:sldChg chg="addSp delSp modSp new">
-        <pc:chgData name="Baráth, Július" userId="S::julius.barath@aos.sk::aebde9b9-dccc-4475-a9ac-c05e78323d7a" providerId="AD" clId="Web-{5EE20A90-31EA-7549-7211-B0E9BADCD073}" dt="2023-12-18T10:21:23.260" v="15" actId="14100"/>
-        <pc:sldMkLst>
-          <pc:docMk/>
-          <pc:sldMk cId="1313297711" sldId="274"/>
-        </pc:sldMkLst>
-      </pc:sldChg>
-      <pc:sldChg chg="addSp modSp new">
-        <pc:chgData name="Baráth, Július" userId="S::julius.barath@aos.sk::aebde9b9-dccc-4475-a9ac-c05e78323d7a" providerId="AD" clId="Web-{5EE20A90-31EA-7549-7211-B0E9BADCD073}" dt="2023-12-18T10:22:13.433" v="19" actId="14100"/>
-        <pc:sldMkLst>
-          <pc:docMk/>
-          <pc:sldMk cId="4108085772" sldId="275"/>
-        </pc:sldMkLst>
-      </pc:sldChg>
-    </pc:docChg>
-  </pc:docChgLst>
-  <pc:docChgLst>
-    <pc:chgData name="Baráth, Július" userId="aebde9b9-dccc-4475-a9ac-c05e78323d7a" providerId="ADAL" clId="{86369A3D-9B98-A74A-849A-7F7BA7A41795}"/>
-    <pc:docChg chg="custSel modSld">
-      <pc:chgData name="Baráth, Július" userId="aebde9b9-dccc-4475-a9ac-c05e78323d7a" providerId="ADAL" clId="{86369A3D-9B98-A74A-849A-7F7BA7A41795}" dt="2025-03-14T10:52:36.146" v="36" actId="1076"/>
-      <pc:docMkLst>
-        <pc:docMk/>
-      </pc:docMkLst>
-      <pc:sldChg chg="modSp mod">
-        <pc:chgData name="Baráth, Július" userId="aebde9b9-dccc-4475-a9ac-c05e78323d7a" providerId="ADAL" clId="{86369A3D-9B98-A74A-849A-7F7BA7A41795}" dt="2025-03-14T10:52:36.146" v="36" actId="1076"/>
+        <pc:chgData name="Baráth, Július" userId="aebde9b9-dccc-4475-a9ac-c05e78323d7a" providerId="ADAL" clId="{4A0811C8-ED2F-505E-B787-C8270CED5046}" dt="2026-02-26T11:49:49.268" v="24" actId="20577"/>
         <pc:sldMkLst>
           <pc:docMk/>
           <pc:sldMk cId="3759222479" sldId="278"/>
         </pc:sldMkLst>
         <pc:spChg chg="mod">
-          <ac:chgData name="Baráth, Július" userId="aebde9b9-dccc-4475-a9ac-c05e78323d7a" providerId="ADAL" clId="{86369A3D-9B98-A74A-849A-7F7BA7A41795}" dt="2025-03-14T10:52:34.594" v="35" actId="27636"/>
+          <ac:chgData name="Baráth, Július" userId="aebde9b9-dccc-4475-a9ac-c05e78323d7a" providerId="ADAL" clId="{4A0811C8-ED2F-505E-B787-C8270CED5046}" dt="2026-02-26T11:49:49.268" v="24" actId="20577"/>
           <ac:spMkLst>
             <pc:docMk/>
             <pc:sldMk cId="3759222479" sldId="278"/>
             <ac:spMk id="3" creationId="{00000000-0000-0000-0000-000000000000}"/>
           </ac:spMkLst>
         </pc:spChg>
-        <pc:picChg chg="mod">
-          <ac:chgData name="Baráth, Július" userId="aebde9b9-dccc-4475-a9ac-c05e78323d7a" providerId="ADAL" clId="{86369A3D-9B98-A74A-849A-7F7BA7A41795}" dt="2025-03-14T10:52:36.146" v="36" actId="1076"/>
-          <ac:picMkLst>
-            <pc:docMk/>
-            <pc:sldMk cId="3759222479" sldId="278"/>
-            <ac:picMk id="4" creationId="{00000000-0000-0000-0000-000000000000}"/>
-          </ac:picMkLst>
-        </pc:picChg>
-      </pc:sldChg>
-    </pc:docChg>
-  </pc:docChgLst>
-  <pc:docChgLst>
-    <pc:chgData name="Július Baráth" userId="e650c4ab-697e-4750-bd58-c1531aabce95" providerId="ADAL" clId="{8863AF68-99C7-814A-983E-0EDA0C7B8258}"/>
-    <pc:docChg chg="custSel modSld">
-      <pc:chgData name="Július Baráth" userId="e650c4ab-697e-4750-bd58-c1531aabce95" providerId="ADAL" clId="{8863AF68-99C7-814A-983E-0EDA0C7B8258}" dt="2022-03-09T13:14:43.676" v="74" actId="108"/>
-      <pc:docMkLst>
-        <pc:docMk/>
-      </pc:docMkLst>
-      <pc:sldChg chg="modSp mod">
-        <pc:chgData name="Július Baráth" userId="e650c4ab-697e-4750-bd58-c1531aabce95" providerId="ADAL" clId="{8863AF68-99C7-814A-983E-0EDA0C7B8258}" dt="2022-03-09T13:14:43.676" v="74" actId="108"/>
-        <pc:sldMkLst>
-          <pc:docMk/>
-          <pc:sldMk cId="0" sldId="267"/>
-        </pc:sldMkLst>
-      </pc:sldChg>
-    </pc:docChg>
-  </pc:docChgLst>
-  <pc:docChgLst>
-    <pc:chgData name="Baráth, Július" userId="S::julius.barath@aos.sk::aebde9b9-dccc-4475-a9ac-c05e78323d7a" providerId="AD" clId="Web-{E55D0627-085A-3FFD-22C4-C5C920C14BF2}"/>
-    <pc:docChg chg="modSld">
-      <pc:chgData name="Baráth, Július" userId="S::julius.barath@aos.sk::aebde9b9-dccc-4475-a9ac-c05e78323d7a" providerId="AD" clId="Web-{E55D0627-085A-3FFD-22C4-C5C920C14BF2}" dt="2023-06-15T13:47:58.719" v="71" actId="20577"/>
-      <pc:docMkLst>
-        <pc:docMk/>
-      </pc:docMkLst>
-      <pc:sldChg chg="modSp">
-        <pc:chgData name="Baráth, Július" userId="S::julius.barath@aos.sk::aebde9b9-dccc-4475-a9ac-c05e78323d7a" providerId="AD" clId="Web-{E55D0627-085A-3FFD-22C4-C5C920C14BF2}" dt="2023-06-15T13:47:58.719" v="71" actId="20577"/>
-        <pc:sldMkLst>
-          <pc:docMk/>
-          <pc:sldMk cId="0" sldId="259"/>
-        </pc:sldMkLst>
       </pc:sldChg>
     </pc:docChg>
   </pc:docChgLst>
@@ -2943,7 +2644,7 @@
           <a:p>
             <a:fld id="{23DE6AA6-8243-4B62-886A-5E6B71847E7F}" type="datetimeFigureOut">
               <a:rPr lang="sk-SK" smtClean="0"/>
-              <a:t>14.3.2025</a:t>
+              <a:t>26.2.2026</a:t>
             </a:fld>
             <a:endParaRPr lang="sk-SK"/>
           </a:p>
@@ -3113,7 +2814,7 @@
           <a:p>
             <a:fld id="{23DE6AA6-8243-4B62-886A-5E6B71847E7F}" type="datetimeFigureOut">
               <a:rPr lang="sk-SK" smtClean="0"/>
-              <a:t>14.3.2025</a:t>
+              <a:t>26.2.2026</a:t>
             </a:fld>
             <a:endParaRPr lang="sk-SK"/>
           </a:p>
@@ -6931,8 +6632,21 @@
             </a:r>
             <a:r>
               <a:rPr lang="sk-SK" sz="2650" dirty="0"/>
-              <a:t> disk</a:t>
-            </a:r>
+              <a:t> –s1 disk </a:t>
+            </a:r>
+            <a:r>
+              <a:rPr lang="sk-SK" sz="2650" dirty="0" err="1"/>
+              <a:t>space</a:t>
+            </a:r>
+            <a:r>
+              <a:rPr lang="sk-SK" sz="2650" dirty="0"/>
+              <a:t> (</a:t>
+            </a:r>
+            <a:r>
+              <a:rPr lang="sk-SK" sz="2650"/>
+              <a:t>len príkazy)</a:t>
+            </a:r>
+            <a:endParaRPr lang="sk-SK" sz="2650" dirty="0"/>
           </a:p>
           <a:p>
             <a:r>

</xml_diff>